<commit_message>
power point dhe word
</commit_message>
<xml_diff>
--- a/prezantimi/PowerPoint/Tema.pptx
+++ b/prezantimi/PowerPoint/Tema.pptx
@@ -8,6 +8,9 @@
     <p:sldId id="256" r:id="rId2"/>
     <p:sldId id="257" r:id="rId3"/>
     <p:sldId id="258" r:id="rId4"/>
+    <p:sldId id="259" r:id="rId5"/>
+    <p:sldId id="260" r:id="rId6"/>
+    <p:sldId id="262" r:id="rId7"/>
   </p:sldIdLst>
   <p:sldSz cx="12192000" cy="6858000"/>
   <p:notesSz cx="6858000" cy="9144000"/>
@@ -3405,8 +3408,8 @@
         </p:nvSpPr>
         <p:spPr>
           <a:xfrm>
-            <a:off x="838200" y="3998260"/>
-            <a:ext cx="10448365" cy="2474258"/>
+            <a:off x="838200" y="1801907"/>
+            <a:ext cx="10448365" cy="4670612"/>
           </a:xfrm>
         </p:spPr>
         <p:txBody>
@@ -3415,22 +3418,50 @@
           </a:bodyPr>
           <a:lstStyle/>
           <a:p>
-            <a:r>
-              <a:rPr lang="sq-AL" dirty="0"/>
+            <a:br>
+              <a:rPr lang="en-US" sz="3800" dirty="0"/>
+            </a:br>
+            <a:br>
+              <a:rPr lang="en-US" sz="3800" dirty="0"/>
+            </a:br>
+            <a:br>
+              <a:rPr lang="en-US" sz="3800" dirty="0"/>
+            </a:br>
+            <a:br>
+              <a:rPr lang="en-US" sz="3800" dirty="0"/>
+            </a:br>
+            <a:endParaRPr lang="en-US" sz="3800" dirty="0"/>
+          </a:p>
+          <a:p>
+            <a:br>
+              <a:rPr lang="en-US" sz="3800" dirty="0"/>
+            </a:br>
+            <a:r>
+              <a:rPr lang="en-US" sz="3800" dirty="0"/>
+              <a:t>- </a:t>
+            </a:r>
+            <a:r>
+              <a:rPr lang="sq-AL" sz="3800" dirty="0"/>
               <a:t>PUNIM DIPLOME</a:t>
             </a:r>
-            <a:endParaRPr lang="en-US" dirty="0"/>
-          </a:p>
-          <a:p>
-            <a:r>
-              <a:rPr lang="sq-AL" b="1" dirty="0"/>
+            <a:r>
+              <a:rPr lang="en-US" sz="3800" dirty="0"/>
+              <a:t> -</a:t>
+            </a:r>
+          </a:p>
+          <a:p>
+            <a:br>
+              <a:rPr lang="en-US" sz="3800" dirty="0"/>
+            </a:br>
+            <a:r>
+              <a:rPr lang="sq-AL" sz="3800" dirty="0"/>
               <a:t>LËNDA:  Orientimi dhe modelimi i objekteve gjeohapësinore</a:t>
             </a:r>
-            <a:endParaRPr lang="en-US" dirty="0"/>
-          </a:p>
-          <a:p>
-            <a:r>
-              <a:rPr lang="sq-AL" b="1" dirty="0"/>
+            <a:endParaRPr lang="en-US" sz="3800" dirty="0"/>
+          </a:p>
+          <a:p>
+            <a:r>
+              <a:rPr lang="sq-AL" sz="3800" dirty="0"/>
               <a:t>TEMA:  Modelimi i të dhënave dhe krijimi i hartës digjitale për rrjetin e ujësjellësit</a:t>
             </a:r>
             <a:br>
@@ -3439,66 +3470,66 @@
             <a:endParaRPr lang="en-US" b="1" dirty="0"/>
           </a:p>
           <a:p>
+            <a:endParaRPr lang="en-US" b="1" dirty="0"/>
+          </a:p>
+          <a:p>
+            <a:endParaRPr lang="en-US" dirty="0"/>
+          </a:p>
+          <a:p>
+            <a:r>
+              <a:rPr lang="sq-AL" sz="3300" b="1" dirty="0"/>
+              <a:t> KANDIDATI:								           MENTORI</a:t>
+            </a:r>
+            <a:r>
+              <a:rPr lang="en-US" sz="3300" b="1" dirty="0"/>
+              <a:t>: </a:t>
+            </a:r>
             <a:br>
-              <a:rPr lang="en-US" b="1" dirty="0"/>
+              <a:rPr lang="en-US" sz="3300" b="1" dirty="0"/>
             </a:br>
-            <a:endParaRPr lang="en-US" dirty="0"/>
-          </a:p>
-          <a:p>
-            <a:r>
-              <a:rPr lang="sq-AL" b="1" dirty="0"/>
-              <a:t> KANDIDATI:								           MENTORI:</a:t>
-            </a:r>
-            <a:endParaRPr lang="en-US" dirty="0"/>
-          </a:p>
-          <a:p>
-            <a:r>
-              <a:rPr lang="sq-AL" b="1" dirty="0"/>
-              <a:t>Valon Sejdiu         	                                                                                          </a:t>
-            </a:r>
-            <a:r>
-              <a:rPr lang="en-US" b="1" dirty="0"/>
-              <a:t>                              </a:t>
-            </a:r>
-            <a:r>
-              <a:rPr lang="sq-AL" b="1" dirty="0"/>
-              <a:t>     </a:t>
-            </a:r>
-            <a:r>
-              <a:rPr lang="en-US" b="1" dirty="0"/>
+            <a:r>
+              <a:rPr lang="en-US" sz="3300" b="1" dirty="0"/>
               <a:t> </a:t>
             </a:r>
             <a:r>
-              <a:rPr lang="sq-AL" b="1" dirty="0"/>
+              <a:rPr lang="sq-AL" sz="3300" b="1" dirty="0"/>
+              <a:t>Valon Sejdiu         	</a:t>
+            </a:r>
+            <a:r>
+              <a:rPr lang="en-US" sz="3300" b="1" dirty="0"/>
+              <a:t>                                                                                                            </a:t>
+            </a:r>
+            <a:r>
+              <a:rPr lang="sq-AL" sz="3300" b="1" dirty="0"/>
               <a:t>Prof.Ass.Dr. Besim Ajvazi</a:t>
             </a:r>
             <a:br>
-              <a:rPr lang="sq-AL" b="1" dirty="0"/>
+              <a:rPr lang="sq-AL" sz="3300" b="1" dirty="0"/>
             </a:br>
             <a:r>
-              <a:rPr lang="en-US" b="1" dirty="0"/>
+              <a:rPr lang="en-US" sz="3300" b="1" dirty="0"/>
               <a:t>         </a:t>
             </a:r>
             <a:br>
-              <a:rPr lang="sq-AL" b="1" dirty="0"/>
+              <a:rPr lang="sq-AL" sz="3300" b="1" dirty="0"/>
             </a:br>
             <a:br>
-              <a:rPr lang="sq-AL" b="1" dirty="0"/>
+              <a:rPr lang="sq-AL" sz="3300" b="1" dirty="0"/>
             </a:br>
             <a:r>
-              <a:rPr lang="sq-AL" dirty="0"/>
+              <a:rPr lang="sq-AL" sz="3300" dirty="0"/>
               <a:t>Prishtinë, Shkurt 2026</a:t>
             </a:r>
-            <a:endParaRPr lang="en-US" dirty="0"/>
+            <a:endParaRPr lang="en-US" sz="3300" dirty="0"/>
           </a:p>
         </p:txBody>
       </p:sp>
       <p:pic>
         <p:nvPicPr>
-          <p:cNvPr id="4" name="Picture 3">
-            <a:extLst>
-              <a:ext uri="{FF2B5EF4-FFF2-40B4-BE49-F238E27FC236}">
-                <a16:creationId xmlns:a16="http://schemas.microsoft.com/office/drawing/2014/main" id="{A9BE1EA4-5FB4-49BF-B4D5-C516AFB76A8F}"/>
+          <p:cNvPr id="5" name="Picture 4">
+            <a:extLst>
+              <a:ext uri="{FF2B5EF4-FFF2-40B4-BE49-F238E27FC236}">
+                <a16:creationId xmlns:a16="http://schemas.microsoft.com/office/drawing/2014/main" id="{3753F273-38F4-4587-BAE3-D4603776A004}"/>
               </a:ext>
             </a:extLst>
           </p:cNvPr>
@@ -3513,8 +3544,44 @@
         </p:blipFill>
         <p:spPr>
           <a:xfrm>
-            <a:off x="4328553" y="1789897"/>
-            <a:ext cx="3857625" cy="2450465"/>
+            <a:off x="4990400" y="1801907"/>
+            <a:ext cx="2109647" cy="1272987"/>
+          </a:xfrm>
+          <a:prstGeom prst="rect">
+            <a:avLst/>
+          </a:prstGeom>
+        </p:spPr>
+      </p:pic>
+      <p:pic>
+        <p:nvPicPr>
+          <p:cNvPr id="6" name="Picture 5">
+            <a:extLst>
+              <a:ext uri="{FF2B5EF4-FFF2-40B4-BE49-F238E27FC236}">
+                <a16:creationId xmlns:a16="http://schemas.microsoft.com/office/drawing/2014/main" id="{D8571C62-168C-409B-9BB7-E2FE26947B0A}"/>
+              </a:ext>
+            </a:extLst>
+          </p:cNvPr>
+          <p:cNvPicPr>
+            <a:picLocks noChangeAspect="1"/>
+          </p:cNvPicPr>
+          <p:nvPr/>
+        </p:nvPicPr>
+        <p:blipFill>
+          <a:blip r:embed="rId3">
+            <a:extLst>
+              <a:ext uri="{28A0092B-C50C-407E-A947-70E740481C1C}">
+                <a14:useLocalDpi xmlns:a14="http://schemas.microsoft.com/office/drawing/2010/main" val="0"/>
+              </a:ext>
+            </a:extLst>
+          </a:blip>
+          <a:stretch>
+            <a:fillRect/>
+          </a:stretch>
+        </p:blipFill>
+        <p:spPr>
+          <a:xfrm>
+            <a:off x="254638" y="0"/>
+            <a:ext cx="11682724" cy="6858000"/>
           </a:xfrm>
           <a:prstGeom prst="rect">
             <a:avLst/>
@@ -3948,11 +4015,7 @@
             </a:r>
             <a:r>
               <a:rPr lang="sq-AL" dirty="0"/>
-              <a:t>.       </a:t>
-            </a:r>
-            <a:r>
-              <a:rPr lang="sq-AL"/>
-              <a:t>6</a:t>
+              <a:t>.       6</a:t>
             </a:r>
             <a:br>
               <a:rPr lang="sq-AL" dirty="0"/>
@@ -4222,6 +4285,264 @@
     <p:extLst>
       <p:ext uri="{BB962C8B-B14F-4D97-AF65-F5344CB8AC3E}">
         <p14:creationId xmlns:p14="http://schemas.microsoft.com/office/powerpoint/2010/main" val="59557974"/>
+      </p:ext>
+    </p:extLst>
+  </p:cSld>
+  <p:clrMapOvr>
+    <a:masterClrMapping/>
+  </p:clrMapOvr>
+</p:sld>
+</file>
+
+<file path=ppt/slides/slide4.xml><?xml version="1.0" encoding="utf-8"?>
+<p:sld xmlns:a="http://schemas.openxmlformats.org/drawingml/2006/main" xmlns:r="http://schemas.openxmlformats.org/officeDocument/2006/relationships" xmlns:p="http://schemas.openxmlformats.org/presentationml/2006/main">
+  <p:cSld>
+    <p:spTree>
+      <p:nvGrpSpPr>
+        <p:cNvPr id="1" name=""/>
+        <p:cNvGrpSpPr/>
+        <p:nvPr/>
+      </p:nvGrpSpPr>
+      <p:grpSpPr>
+        <a:xfrm>
+          <a:off x="0" y="0"/>
+          <a:ext cx="0" cy="0"/>
+          <a:chOff x="0" y="0"/>
+          <a:chExt cx="0" cy="0"/>
+        </a:xfrm>
+      </p:grpSpPr>
+      <p:pic>
+        <p:nvPicPr>
+          <p:cNvPr id="5" name="Content Placeholder 4">
+            <a:extLst>
+              <a:ext uri="{FF2B5EF4-FFF2-40B4-BE49-F238E27FC236}">
+                <a16:creationId xmlns:a16="http://schemas.microsoft.com/office/drawing/2014/main" id="{4C344D03-8450-4202-994D-16DF8B42696B}"/>
+              </a:ext>
+            </a:extLst>
+          </p:cNvPr>
+          <p:cNvPicPr>
+            <a:picLocks noGrp="1" noChangeAspect="1"/>
+          </p:cNvPicPr>
+          <p:nvPr>
+            <p:ph idx="1"/>
+          </p:nvPr>
+        </p:nvPicPr>
+        <p:blipFill>
+          <a:blip r:embed="rId2">
+            <a:extLst>
+              <a:ext uri="{28A0092B-C50C-407E-A947-70E740481C1C}">
+                <a14:useLocalDpi xmlns:a14="http://schemas.microsoft.com/office/drawing/2010/main" val="0"/>
+              </a:ext>
+            </a:extLst>
+          </a:blip>
+          <a:stretch>
+            <a:fillRect/>
+          </a:stretch>
+        </p:blipFill>
+        <p:spPr>
+          <a:xfrm>
+            <a:off x="667908" y="242598"/>
+            <a:ext cx="10856183" cy="6372804"/>
+          </a:xfrm>
+        </p:spPr>
+      </p:pic>
+    </p:spTree>
+    <p:extLst>
+      <p:ext uri="{BB962C8B-B14F-4D97-AF65-F5344CB8AC3E}">
+        <p14:creationId xmlns:p14="http://schemas.microsoft.com/office/powerpoint/2010/main" val="3148911821"/>
+      </p:ext>
+    </p:extLst>
+  </p:cSld>
+  <p:clrMapOvr>
+    <a:masterClrMapping/>
+  </p:clrMapOvr>
+</p:sld>
+</file>
+
+<file path=ppt/slides/slide5.xml><?xml version="1.0" encoding="utf-8"?>
+<p:sld xmlns:a="http://schemas.openxmlformats.org/drawingml/2006/main" xmlns:r="http://schemas.openxmlformats.org/officeDocument/2006/relationships" xmlns:p="http://schemas.openxmlformats.org/presentationml/2006/main">
+  <p:cSld>
+    <p:spTree>
+      <p:nvGrpSpPr>
+        <p:cNvPr id="1" name=""/>
+        <p:cNvGrpSpPr/>
+        <p:nvPr/>
+      </p:nvGrpSpPr>
+      <p:grpSpPr>
+        <a:xfrm>
+          <a:off x="0" y="0"/>
+          <a:ext cx="0" cy="0"/>
+          <a:chOff x="0" y="0"/>
+          <a:chExt cx="0" cy="0"/>
+        </a:xfrm>
+      </p:grpSpPr>
+      <p:sp>
+        <p:nvSpPr>
+          <p:cNvPr id="2" name="Title 1">
+            <a:extLst>
+              <a:ext uri="{FF2B5EF4-FFF2-40B4-BE49-F238E27FC236}">
+                <a16:creationId xmlns:a16="http://schemas.microsoft.com/office/drawing/2014/main" id="{CE9F325B-2F7A-47E3-A4C9-C38C37AA8DF3}"/>
+              </a:ext>
+            </a:extLst>
+          </p:cNvPr>
+          <p:cNvSpPr>
+            <a:spLocks noGrp="1"/>
+          </p:cNvSpPr>
+          <p:nvPr>
+            <p:ph type="title"/>
+          </p:nvPr>
+        </p:nvSpPr>
+        <p:spPr/>
+        <p:txBody>
+          <a:bodyPr/>
+          <a:lstStyle/>
+          <a:p>
+            <a:r>
+              <a:rPr lang="sq-AL" b="1" dirty="0"/>
+              <a:t>Modelimi i të Dhënave dhe Klasifikimi i Komponenteve të Sistemit</a:t>
+            </a:r>
+            <a:endParaRPr lang="en-US" dirty="0"/>
+          </a:p>
+        </p:txBody>
+      </p:sp>
+      <p:sp>
+        <p:nvSpPr>
+          <p:cNvPr id="3" name="Content Placeholder 2">
+            <a:extLst>
+              <a:ext uri="{FF2B5EF4-FFF2-40B4-BE49-F238E27FC236}">
+                <a16:creationId xmlns:a16="http://schemas.microsoft.com/office/drawing/2014/main" id="{EC932AB6-E67E-4E01-9D71-813161D95067}"/>
+              </a:ext>
+            </a:extLst>
+          </p:cNvPr>
+          <p:cNvSpPr>
+            <a:spLocks noGrp="1"/>
+          </p:cNvSpPr>
+          <p:nvPr>
+            <p:ph idx="1"/>
+          </p:nvPr>
+        </p:nvSpPr>
+        <p:spPr/>
+        <p:txBody>
+          <a:bodyPr/>
+          <a:lstStyle/>
+          <a:p>
+            <a:r>
+              <a:rPr lang="sq-AL" b="1" dirty="0"/>
+              <a:t>Modelimi i të Dhënave dhe Klasifikimi i Komponenteve të Sistemit</a:t>
+            </a:r>
+            <a:br>
+              <a:rPr lang="en-US" b="1" dirty="0"/>
+            </a:br>
+            <a:r>
+              <a:rPr lang="sq-AL" dirty="0"/>
+              <a:t>Të dhënat e rrugëve </a:t>
+            </a:r>
+            <a:br>
+              <a:rPr lang="en-US" dirty="0"/>
+            </a:br>
+            <a:r>
+              <a:rPr lang="en-US" dirty="0"/>
+              <a:t>N</a:t>
+            </a:r>
+            <a:r>
+              <a:rPr lang="sq-AL" dirty="0"/>
+              <a:t>dërtesat</a:t>
+            </a:r>
+            <a:r>
+              <a:rPr lang="en-US" dirty="0"/>
+              <a:t> / S</a:t>
+            </a:r>
+            <a:r>
+              <a:rPr lang="sq-AL" dirty="0"/>
+              <a:t>htëpitë</a:t>
+            </a:r>
+            <a:br>
+              <a:rPr lang="en-US" dirty="0"/>
+            </a:br>
+            <a:r>
+              <a:rPr lang="sq-AL" dirty="0"/>
+              <a:t>konsumatorët ose pronarët  </a:t>
+            </a:r>
+            <a:endParaRPr lang="en-US" dirty="0"/>
+          </a:p>
+          <a:p>
+            <a:endParaRPr lang="en-US" dirty="0"/>
+          </a:p>
+        </p:txBody>
+      </p:sp>
+    </p:spTree>
+    <p:extLst>
+      <p:ext uri="{BB962C8B-B14F-4D97-AF65-F5344CB8AC3E}">
+        <p14:creationId xmlns:p14="http://schemas.microsoft.com/office/powerpoint/2010/main" val="4053017133"/>
+      </p:ext>
+    </p:extLst>
+  </p:cSld>
+  <p:clrMapOvr>
+    <a:masterClrMapping/>
+  </p:clrMapOvr>
+</p:sld>
+</file>
+
+<file path=ppt/slides/slide6.xml><?xml version="1.0" encoding="utf-8"?>
+<p:sld xmlns:a="http://schemas.openxmlformats.org/drawingml/2006/main" xmlns:r="http://schemas.openxmlformats.org/officeDocument/2006/relationships" xmlns:p="http://schemas.openxmlformats.org/presentationml/2006/main">
+  <p:cSld>
+    <p:spTree>
+      <p:nvGrpSpPr>
+        <p:cNvPr id="1" name=""/>
+        <p:cNvGrpSpPr/>
+        <p:nvPr/>
+      </p:nvGrpSpPr>
+      <p:grpSpPr>
+        <a:xfrm>
+          <a:off x="0" y="0"/>
+          <a:ext cx="0" cy="0"/>
+          <a:chOff x="0" y="0"/>
+          <a:chExt cx="0" cy="0"/>
+        </a:xfrm>
+      </p:grpSpPr>
+      <p:pic>
+        <p:nvPicPr>
+          <p:cNvPr id="4" name="pic">
+            <a:extLst>
+              <a:ext uri="{FF2B5EF4-FFF2-40B4-BE49-F238E27FC236}">
+                <a16:creationId xmlns:a16="http://schemas.microsoft.com/office/drawing/2014/main" id="{533AE1F9-EA20-4A3F-85BD-0FAE2101D9EB}"/>
+              </a:ext>
+            </a:extLst>
+          </p:cNvPr>
+          <p:cNvPicPr>
+            <a:picLocks noGrp="1" noChangeAspect="1"/>
+          </p:cNvPicPr>
+          <p:nvPr>
+            <p:ph idx="1"/>
+          </p:nvPr>
+        </p:nvPicPr>
+        <p:blipFill>
+          <a:blip r:embed="rId2">
+            <a:extLst>
+              <a:ext uri="{28A0092B-C50C-407E-A947-70E740481C1C}">
+                <a14:useLocalDpi xmlns:a14="http://schemas.microsoft.com/office/drawing/2010/main" val="0"/>
+              </a:ext>
+            </a:extLst>
+          </a:blip>
+          <a:srcRect/>
+          <a:stretch>
+            <a:fillRect/>
+          </a:stretch>
+        </p:blipFill>
+        <p:spPr>
+          <a:xfrm>
+            <a:off x="1216057" y="480980"/>
+            <a:ext cx="9473939" cy="7249760"/>
+          </a:xfrm>
+          <a:prstGeom prst="rect">
+            <a:avLst/>
+          </a:prstGeom>
+        </p:spPr>
+      </p:pic>
+    </p:spTree>
+    <p:extLst>
+      <p:ext uri="{BB962C8B-B14F-4D97-AF65-F5344CB8AC3E}">
+        <p14:creationId xmlns:p14="http://schemas.microsoft.com/office/powerpoint/2010/main" val="867436256"/>
       </p:ext>
     </p:extLst>
   </p:cSld>

</xml_diff>

<commit_message>
word i bere per dorezim es bashku me pdf dhe update powerpoint
</commit_message>
<xml_diff>
--- a/prezantimi/PowerPoint/Tema.pptx
+++ b/prezantimi/PowerPoint/Tema.pptx
@@ -7,10 +7,13 @@
   <p:sldIdLst>
     <p:sldId id="256" r:id="rId2"/>
     <p:sldId id="258" r:id="rId3"/>
-    <p:sldId id="257" r:id="rId4"/>
-    <p:sldId id="260" r:id="rId5"/>
-    <p:sldId id="262" r:id="rId6"/>
-    <p:sldId id="263" r:id="rId7"/>
+    <p:sldId id="264" r:id="rId4"/>
+    <p:sldId id="266" r:id="rId5"/>
+    <p:sldId id="257" r:id="rId6"/>
+    <p:sldId id="260" r:id="rId7"/>
+    <p:sldId id="262" r:id="rId8"/>
+    <p:sldId id="263" r:id="rId9"/>
+    <p:sldId id="265" r:id="rId10"/>
   </p:sldIdLst>
   <p:sldSz cx="12192000" cy="6858000"/>
   <p:notesSz cx="6858000" cy="9144000"/>
@@ -264,7 +267,7 @@
           <a:p>
             <a:fld id="{32F29B0A-3237-420D-965D-CD20C911ADA0}" type="datetimeFigureOut">
               <a:rPr lang="en-US" smtClean="0"/>
-              <a:t>2/6/2026</a:t>
+              <a:t>2/10/2026</a:t>
             </a:fld>
             <a:endParaRPr lang="en-US"/>
           </a:p>
@@ -462,7 +465,7 @@
           <a:p>
             <a:fld id="{32F29B0A-3237-420D-965D-CD20C911ADA0}" type="datetimeFigureOut">
               <a:rPr lang="en-US" smtClean="0"/>
-              <a:t>2/6/2026</a:t>
+              <a:t>2/10/2026</a:t>
             </a:fld>
             <a:endParaRPr lang="en-US"/>
           </a:p>
@@ -670,7 +673,7 @@
           <a:p>
             <a:fld id="{32F29B0A-3237-420D-965D-CD20C911ADA0}" type="datetimeFigureOut">
               <a:rPr lang="en-US" smtClean="0"/>
-              <a:t>2/6/2026</a:t>
+              <a:t>2/10/2026</a:t>
             </a:fld>
             <a:endParaRPr lang="en-US"/>
           </a:p>
@@ -868,7 +871,7 @@
           <a:p>
             <a:fld id="{32F29B0A-3237-420D-965D-CD20C911ADA0}" type="datetimeFigureOut">
               <a:rPr lang="en-US" smtClean="0"/>
-              <a:t>2/6/2026</a:t>
+              <a:t>2/10/2026</a:t>
             </a:fld>
             <a:endParaRPr lang="en-US"/>
           </a:p>
@@ -1143,7 +1146,7 @@
           <a:p>
             <a:fld id="{32F29B0A-3237-420D-965D-CD20C911ADA0}" type="datetimeFigureOut">
               <a:rPr lang="en-US" smtClean="0"/>
-              <a:t>2/6/2026</a:t>
+              <a:t>2/10/2026</a:t>
             </a:fld>
             <a:endParaRPr lang="en-US"/>
           </a:p>
@@ -1408,7 +1411,7 @@
           <a:p>
             <a:fld id="{32F29B0A-3237-420D-965D-CD20C911ADA0}" type="datetimeFigureOut">
               <a:rPr lang="en-US" smtClean="0"/>
-              <a:t>2/6/2026</a:t>
+              <a:t>2/10/2026</a:t>
             </a:fld>
             <a:endParaRPr lang="en-US"/>
           </a:p>
@@ -1820,7 +1823,7 @@
           <a:p>
             <a:fld id="{32F29B0A-3237-420D-965D-CD20C911ADA0}" type="datetimeFigureOut">
               <a:rPr lang="en-US" smtClean="0"/>
-              <a:t>2/6/2026</a:t>
+              <a:t>2/10/2026</a:t>
             </a:fld>
             <a:endParaRPr lang="en-US"/>
           </a:p>
@@ -1961,7 +1964,7 @@
           <a:p>
             <a:fld id="{32F29B0A-3237-420D-965D-CD20C911ADA0}" type="datetimeFigureOut">
               <a:rPr lang="en-US" smtClean="0"/>
-              <a:t>2/6/2026</a:t>
+              <a:t>2/10/2026</a:t>
             </a:fld>
             <a:endParaRPr lang="en-US"/>
           </a:p>
@@ -2074,7 +2077,7 @@
           <a:p>
             <a:fld id="{32F29B0A-3237-420D-965D-CD20C911ADA0}" type="datetimeFigureOut">
               <a:rPr lang="en-US" smtClean="0"/>
-              <a:t>2/6/2026</a:t>
+              <a:t>2/10/2026</a:t>
             </a:fld>
             <a:endParaRPr lang="en-US"/>
           </a:p>
@@ -2385,7 +2388,7 @@
           <a:p>
             <a:fld id="{32F29B0A-3237-420D-965D-CD20C911ADA0}" type="datetimeFigureOut">
               <a:rPr lang="en-US" smtClean="0"/>
-              <a:t>2/6/2026</a:t>
+              <a:t>2/10/2026</a:t>
             </a:fld>
             <a:endParaRPr lang="en-US"/>
           </a:p>
@@ -2673,7 +2676,7 @@
           <a:p>
             <a:fld id="{32F29B0A-3237-420D-965D-CD20C911ADA0}" type="datetimeFigureOut">
               <a:rPr lang="en-US" smtClean="0"/>
-              <a:t>2/6/2026</a:t>
+              <a:t>2/10/2026</a:t>
             </a:fld>
             <a:endParaRPr lang="en-US"/>
           </a:p>
@@ -2914,7 +2917,7 @@
           <a:p>
             <a:fld id="{32F29B0A-3237-420D-965D-CD20C911ADA0}" type="datetimeFigureOut">
               <a:rPr lang="en-US" smtClean="0"/>
-              <a:t>2/6/2026</a:t>
+              <a:t>2/10/2026</a:t>
             </a:fld>
             <a:endParaRPr lang="en-US"/>
           </a:p>
@@ -4816,6 +4819,627 @@
           <p:cNvPr id="2" name="Title 1">
             <a:extLst>
               <a:ext uri="{FF2B5EF4-FFF2-40B4-BE49-F238E27FC236}">
+                <a16:creationId xmlns:a16="http://schemas.microsoft.com/office/drawing/2014/main" id="{FAA88C77-35B6-4E66-B02C-AEF7EBFDEEFC}"/>
+              </a:ext>
+            </a:extLst>
+          </p:cNvPr>
+          <p:cNvSpPr>
+            <a:spLocks noGrp="1"/>
+          </p:cNvSpPr>
+          <p:nvPr>
+            <p:ph type="title"/>
+          </p:nvPr>
+        </p:nvSpPr>
+        <p:spPr/>
+        <p:txBody>
+          <a:bodyPr>
+            <a:normAutofit/>
+          </a:bodyPr>
+          <a:lstStyle/>
+          <a:p>
+            <a:r>
+              <a:rPr lang="sq-AL" sz="2500" b="1" dirty="0">
+                <a:latin typeface="Times New Roman" panose="02020603050405020304" pitchFamily="18" charset="0"/>
+                <a:cs typeface="Times New Roman" panose="02020603050405020304" pitchFamily="18" charset="0"/>
+              </a:rPr>
+              <a:t>Përmbajtja</a:t>
+            </a:r>
+            <a:endParaRPr lang="en-US" sz="2500" dirty="0">
+              <a:latin typeface="Times New Roman" panose="02020603050405020304" pitchFamily="18" charset="0"/>
+              <a:cs typeface="Times New Roman" panose="02020603050405020304" pitchFamily="18" charset="0"/>
+            </a:endParaRPr>
+          </a:p>
+        </p:txBody>
+      </p:sp>
+      <p:sp>
+        <p:nvSpPr>
+          <p:cNvPr id="3" name="Content Placeholder 2">
+            <a:extLst>
+              <a:ext uri="{FF2B5EF4-FFF2-40B4-BE49-F238E27FC236}">
+                <a16:creationId xmlns:a16="http://schemas.microsoft.com/office/drawing/2014/main" id="{0B840AFE-B3E2-4AE0-A709-018B60F648FE}"/>
+              </a:ext>
+            </a:extLst>
+          </p:cNvPr>
+          <p:cNvSpPr>
+            <a:spLocks noGrp="1"/>
+          </p:cNvSpPr>
+          <p:nvPr>
+            <p:ph idx="1"/>
+          </p:nvPr>
+        </p:nvSpPr>
+        <p:spPr>
+          <a:xfrm>
+            <a:off x="838200" y="1825625"/>
+            <a:ext cx="10515600" cy="4351338"/>
+          </a:xfrm>
+        </p:spPr>
+        <p:txBody>
+          <a:bodyPr>
+            <a:normAutofit lnSpcReduction="10000"/>
+          </a:bodyPr>
+          <a:lstStyle/>
+          <a:p>
+            <a:pPr marL="457200" indent="-457200">
+              <a:buAutoNum type="alphaLcParenR"/>
+            </a:pPr>
+            <a:r>
+              <a:rPr lang="en-US" sz="2000" dirty="0" err="1">
+                <a:latin typeface="Times New Roman" panose="02020603050405020304" pitchFamily="18" charset="0"/>
+                <a:cs typeface="Times New Roman" panose="02020603050405020304" pitchFamily="18" charset="0"/>
+              </a:rPr>
+              <a:t>Pjesa</a:t>
+            </a:r>
+            <a:r>
+              <a:rPr lang="en-US" sz="2000" dirty="0">
+                <a:latin typeface="Times New Roman" panose="02020603050405020304" pitchFamily="18" charset="0"/>
+                <a:cs typeface="Times New Roman" panose="02020603050405020304" pitchFamily="18" charset="0"/>
+              </a:rPr>
+              <a:t> e </a:t>
+            </a:r>
+            <a:r>
+              <a:rPr lang="en-US" sz="2000" dirty="0" err="1">
+                <a:latin typeface="Times New Roman" panose="02020603050405020304" pitchFamily="18" charset="0"/>
+                <a:cs typeface="Times New Roman" panose="02020603050405020304" pitchFamily="18" charset="0"/>
+              </a:rPr>
+              <a:t>parë</a:t>
+            </a:r>
+            <a:br>
+              <a:rPr lang="en-US" dirty="0"/>
+            </a:br>
+            <a:r>
+              <a:rPr lang="en-US" dirty="0"/>
+              <a:t>   </a:t>
+            </a:r>
+            <a:r>
+              <a:rPr lang="en-US" sz="1500" dirty="0">
+                <a:latin typeface="Times New Roman" panose="02020603050405020304" pitchFamily="18" charset="0"/>
+                <a:cs typeface="Times New Roman" panose="02020603050405020304" pitchFamily="18" charset="0"/>
+              </a:rPr>
+              <a:t>1.</a:t>
+            </a:r>
+            <a:r>
+              <a:rPr lang="sq-AL" sz="1500" dirty="0">
+                <a:latin typeface="Times New Roman" panose="02020603050405020304" pitchFamily="18" charset="0"/>
+                <a:cs typeface="Times New Roman" panose="02020603050405020304" pitchFamily="18" charset="0"/>
+              </a:rPr>
+              <a:t>Problematika e menaxhimit të ujësjellësit </a:t>
+            </a:r>
+            <a:br>
+              <a:rPr lang="en-US" sz="1200" dirty="0"/>
+            </a:br>
+            <a:r>
+              <a:rPr lang="en-US" sz="1200" dirty="0"/>
+              <a:t>       </a:t>
+            </a:r>
+            <a:r>
+              <a:rPr lang="en-US" sz="1500" dirty="0">
+                <a:latin typeface="Times New Roman" panose="02020603050405020304" pitchFamily="18" charset="0"/>
+                <a:cs typeface="Times New Roman" panose="02020603050405020304" pitchFamily="18" charset="0"/>
+              </a:rPr>
+              <a:t>2.</a:t>
+            </a:r>
+            <a:r>
+              <a:rPr lang="sq-AL" sz="1500" dirty="0">
+                <a:latin typeface="Times New Roman" panose="02020603050405020304" pitchFamily="18" charset="0"/>
+                <a:cs typeface="Times New Roman" panose="02020603050405020304" pitchFamily="18" charset="0"/>
+              </a:rPr>
+              <a:t>Qëllimi dhe objektivat e punimit </a:t>
+            </a:r>
+            <a:endParaRPr lang="en-US" sz="1500" dirty="0">
+              <a:latin typeface="Times New Roman" panose="02020603050405020304" pitchFamily="18" charset="0"/>
+              <a:cs typeface="Times New Roman" panose="02020603050405020304" pitchFamily="18" charset="0"/>
+            </a:endParaRPr>
+          </a:p>
+          <a:p>
+            <a:pPr marL="457200" indent="-457200">
+              <a:buAutoNum type="alphaLcParenR"/>
+            </a:pPr>
+            <a:r>
+              <a:rPr lang="en-US" sz="2000" dirty="0" err="1">
+                <a:latin typeface="Times New Roman" panose="02020603050405020304" pitchFamily="18" charset="0"/>
+                <a:cs typeface="Times New Roman" panose="02020603050405020304" pitchFamily="18" charset="0"/>
+              </a:rPr>
+              <a:t>Pjesa</a:t>
+            </a:r>
+            <a:r>
+              <a:rPr lang="en-US" sz="2000" dirty="0">
+                <a:latin typeface="Times New Roman" panose="02020603050405020304" pitchFamily="18" charset="0"/>
+                <a:cs typeface="Times New Roman" panose="02020603050405020304" pitchFamily="18" charset="0"/>
+              </a:rPr>
+              <a:t> e </a:t>
+            </a:r>
+            <a:r>
+              <a:rPr lang="en-US" sz="2000" dirty="0" err="1">
+                <a:latin typeface="Times New Roman" panose="02020603050405020304" pitchFamily="18" charset="0"/>
+                <a:cs typeface="Times New Roman" panose="02020603050405020304" pitchFamily="18" charset="0"/>
+              </a:rPr>
+              <a:t>dytë</a:t>
+            </a:r>
+            <a:r>
+              <a:rPr lang="en-US" sz="2000" dirty="0">
+                <a:latin typeface="Times New Roman" panose="02020603050405020304" pitchFamily="18" charset="0"/>
+                <a:cs typeface="Times New Roman" panose="02020603050405020304" pitchFamily="18" charset="0"/>
+              </a:rPr>
+              <a:t> </a:t>
+            </a:r>
+          </a:p>
+          <a:p>
+            <a:pPr marL="0" indent="0">
+              <a:buNone/>
+            </a:pPr>
+            <a:r>
+              <a:rPr lang="en-US" sz="2000" dirty="0">
+                <a:latin typeface="Times New Roman" panose="02020603050405020304" pitchFamily="18" charset="0"/>
+                <a:cs typeface="Times New Roman" panose="02020603050405020304" pitchFamily="18" charset="0"/>
+              </a:rPr>
+              <a:t>           </a:t>
+            </a:r>
+            <a:r>
+              <a:rPr lang="en-US" sz="1500" dirty="0">
+                <a:latin typeface="Times New Roman" panose="02020603050405020304" pitchFamily="18" charset="0"/>
+                <a:cs typeface="Times New Roman" panose="02020603050405020304" pitchFamily="18" charset="0"/>
+              </a:rPr>
+              <a:t>3.Grumbullimi </a:t>
+            </a:r>
+            <a:r>
+              <a:rPr lang="en-US" sz="1500" dirty="0" err="1">
+                <a:latin typeface="Times New Roman" panose="02020603050405020304" pitchFamily="18" charset="0"/>
+                <a:cs typeface="Times New Roman" panose="02020603050405020304" pitchFamily="18" charset="0"/>
+              </a:rPr>
+              <a:t>i</a:t>
+            </a:r>
+            <a:r>
+              <a:rPr lang="en-US" sz="1500" dirty="0">
+                <a:latin typeface="Times New Roman" panose="02020603050405020304" pitchFamily="18" charset="0"/>
+                <a:cs typeface="Times New Roman" panose="02020603050405020304" pitchFamily="18" charset="0"/>
+              </a:rPr>
+              <a:t> </a:t>
+            </a:r>
+            <a:r>
+              <a:rPr lang="en-US" sz="1500" dirty="0" err="1">
+                <a:latin typeface="Times New Roman" panose="02020603050405020304" pitchFamily="18" charset="0"/>
+                <a:cs typeface="Times New Roman" panose="02020603050405020304" pitchFamily="18" charset="0"/>
+              </a:rPr>
+              <a:t>të</a:t>
+            </a:r>
+            <a:r>
+              <a:rPr lang="en-US" sz="1500" dirty="0">
+                <a:latin typeface="Times New Roman" panose="02020603050405020304" pitchFamily="18" charset="0"/>
+                <a:cs typeface="Times New Roman" panose="02020603050405020304" pitchFamily="18" charset="0"/>
+              </a:rPr>
+              <a:t> </a:t>
+            </a:r>
+            <a:r>
+              <a:rPr lang="en-US" sz="1500" dirty="0" err="1">
+                <a:latin typeface="Times New Roman" panose="02020603050405020304" pitchFamily="18" charset="0"/>
+                <a:cs typeface="Times New Roman" panose="02020603050405020304" pitchFamily="18" charset="0"/>
+              </a:rPr>
+              <a:t>dhënave</a:t>
+            </a:r>
+            <a:br>
+              <a:rPr lang="en-US" sz="1500" dirty="0">
+                <a:latin typeface="Times New Roman" panose="02020603050405020304" pitchFamily="18" charset="0"/>
+                <a:cs typeface="Times New Roman" panose="02020603050405020304" pitchFamily="18" charset="0"/>
+              </a:rPr>
+            </a:br>
+            <a:r>
+              <a:rPr lang="en-US" sz="1500" dirty="0">
+                <a:latin typeface="Times New Roman" panose="02020603050405020304" pitchFamily="18" charset="0"/>
+                <a:cs typeface="Times New Roman" panose="02020603050405020304" pitchFamily="18" charset="0"/>
+              </a:rPr>
+              <a:t>              4</a:t>
+            </a:r>
+            <a:r>
+              <a:rPr lang="sq-AL" sz="1500" dirty="0">
+                <a:latin typeface="Times New Roman" panose="02020603050405020304" pitchFamily="18" charset="0"/>
+                <a:cs typeface="Times New Roman" panose="02020603050405020304" pitchFamily="18" charset="0"/>
+              </a:rPr>
+              <a:t>. Modelimi i të dhënave dhe klasifikimi i komponenteve të sistemit </a:t>
+            </a:r>
+            <a:endParaRPr lang="en-US" sz="1500" dirty="0">
+              <a:latin typeface="Times New Roman" panose="02020603050405020304" pitchFamily="18" charset="0"/>
+              <a:cs typeface="Times New Roman" panose="02020603050405020304" pitchFamily="18" charset="0"/>
+            </a:endParaRPr>
+          </a:p>
+          <a:p>
+            <a:pPr marL="0" indent="0">
+              <a:buNone/>
+            </a:pPr>
+            <a:r>
+              <a:rPr lang="en-US" sz="2000" dirty="0">
+                <a:latin typeface="Times New Roman" panose="02020603050405020304" pitchFamily="18" charset="0"/>
+                <a:cs typeface="Times New Roman" panose="02020603050405020304" pitchFamily="18" charset="0"/>
+              </a:rPr>
+              <a:t>c)    </a:t>
+            </a:r>
+            <a:r>
+              <a:rPr lang="en-US" sz="2000" dirty="0" err="1">
+                <a:latin typeface="Times New Roman" panose="02020603050405020304" pitchFamily="18" charset="0"/>
+                <a:cs typeface="Times New Roman" panose="02020603050405020304" pitchFamily="18" charset="0"/>
+              </a:rPr>
+              <a:t>Pjesa</a:t>
+            </a:r>
+            <a:r>
+              <a:rPr lang="en-US" sz="2000" dirty="0">
+                <a:latin typeface="Times New Roman" panose="02020603050405020304" pitchFamily="18" charset="0"/>
+                <a:cs typeface="Times New Roman" panose="02020603050405020304" pitchFamily="18" charset="0"/>
+              </a:rPr>
+              <a:t> e </a:t>
+            </a:r>
+            <a:r>
+              <a:rPr lang="en-US" sz="2000" dirty="0" err="1">
+                <a:latin typeface="Times New Roman" panose="02020603050405020304" pitchFamily="18" charset="0"/>
+                <a:cs typeface="Times New Roman" panose="02020603050405020304" pitchFamily="18" charset="0"/>
+              </a:rPr>
+              <a:t>tretë</a:t>
+            </a:r>
+            <a:br>
+              <a:rPr lang="en-US" sz="1500" dirty="0">
+                <a:latin typeface="Times New Roman" panose="02020603050405020304" pitchFamily="18" charset="0"/>
+                <a:cs typeface="Times New Roman" panose="02020603050405020304" pitchFamily="18" charset="0"/>
+              </a:rPr>
+            </a:br>
+            <a:r>
+              <a:rPr lang="en-US" sz="1500" dirty="0">
+                <a:latin typeface="Times New Roman" panose="02020603050405020304" pitchFamily="18" charset="0"/>
+                <a:cs typeface="Times New Roman" panose="02020603050405020304" pitchFamily="18" charset="0"/>
+              </a:rPr>
+              <a:t>            </a:t>
+            </a:r>
+            <a:br>
+              <a:rPr lang="en-US" sz="1500" dirty="0">
+                <a:latin typeface="Times New Roman" panose="02020603050405020304" pitchFamily="18" charset="0"/>
+                <a:cs typeface="Times New Roman" panose="02020603050405020304" pitchFamily="18" charset="0"/>
+              </a:rPr>
+            </a:br>
+            <a:r>
+              <a:rPr lang="en-US" sz="1500" dirty="0">
+                <a:latin typeface="Times New Roman" panose="02020603050405020304" pitchFamily="18" charset="0"/>
+                <a:cs typeface="Times New Roman" panose="02020603050405020304" pitchFamily="18" charset="0"/>
+              </a:rPr>
+              <a:t>              5.</a:t>
+            </a:r>
+            <a:r>
+              <a:rPr lang="sq-AL" sz="1500" dirty="0">
+                <a:latin typeface="Times New Roman" panose="02020603050405020304" pitchFamily="18" charset="0"/>
+                <a:cs typeface="Times New Roman" panose="02020603050405020304" pitchFamily="18" charset="0"/>
+              </a:rPr>
+              <a:t>Krijimi i hartave digjitale </a:t>
+            </a:r>
+            <a:br>
+              <a:rPr lang="en-US" sz="1500" dirty="0">
+                <a:latin typeface="Times New Roman" panose="02020603050405020304" pitchFamily="18" charset="0"/>
+                <a:cs typeface="Times New Roman" panose="02020603050405020304" pitchFamily="18" charset="0"/>
+              </a:rPr>
+            </a:br>
+            <a:r>
+              <a:rPr lang="en-US" sz="1500" dirty="0">
+                <a:latin typeface="Times New Roman" panose="02020603050405020304" pitchFamily="18" charset="0"/>
+                <a:cs typeface="Times New Roman" panose="02020603050405020304" pitchFamily="18" charset="0"/>
+              </a:rPr>
+              <a:t>              6.</a:t>
+            </a:r>
+            <a:r>
+              <a:rPr lang="sq-AL" sz="1500" dirty="0">
+                <a:latin typeface="Times New Roman" panose="02020603050405020304" pitchFamily="18" charset="0"/>
+                <a:cs typeface="Times New Roman" panose="02020603050405020304" pitchFamily="18" charset="0"/>
+              </a:rPr>
+              <a:t> Simbologjia e përdorur </a:t>
+            </a:r>
+            <a:br>
+              <a:rPr lang="en-US" sz="1500" dirty="0">
+                <a:latin typeface="Times New Roman" panose="02020603050405020304" pitchFamily="18" charset="0"/>
+                <a:cs typeface="Times New Roman" panose="02020603050405020304" pitchFamily="18" charset="0"/>
+              </a:rPr>
+            </a:br>
+            <a:br>
+              <a:rPr lang="en-US" sz="1500" dirty="0">
+                <a:latin typeface="Times New Roman" panose="02020603050405020304" pitchFamily="18" charset="0"/>
+                <a:cs typeface="Times New Roman" panose="02020603050405020304" pitchFamily="18" charset="0"/>
+              </a:rPr>
+            </a:br>
+            <a:r>
+              <a:rPr lang="en-US" sz="2000" dirty="0">
+                <a:latin typeface="Times New Roman" panose="02020603050405020304" pitchFamily="18" charset="0"/>
+                <a:cs typeface="Times New Roman" panose="02020603050405020304" pitchFamily="18" charset="0"/>
+              </a:rPr>
+              <a:t>d)     </a:t>
+            </a:r>
+            <a:r>
+              <a:rPr lang="en-US" sz="2000" dirty="0" err="1">
+                <a:latin typeface="Times New Roman" panose="02020603050405020304" pitchFamily="18" charset="0"/>
+                <a:cs typeface="Times New Roman" panose="02020603050405020304" pitchFamily="18" charset="0"/>
+              </a:rPr>
+              <a:t>Pjesa</a:t>
+            </a:r>
+            <a:r>
+              <a:rPr lang="en-US" sz="2000" dirty="0">
+                <a:latin typeface="Times New Roman" panose="02020603050405020304" pitchFamily="18" charset="0"/>
+                <a:cs typeface="Times New Roman" panose="02020603050405020304" pitchFamily="18" charset="0"/>
+              </a:rPr>
+              <a:t> e </a:t>
+            </a:r>
+            <a:r>
+              <a:rPr lang="en-US" sz="2000" dirty="0" err="1">
+                <a:latin typeface="Times New Roman" panose="02020603050405020304" pitchFamily="18" charset="0"/>
+                <a:cs typeface="Times New Roman" panose="02020603050405020304" pitchFamily="18" charset="0"/>
+              </a:rPr>
+              <a:t>katërt</a:t>
+            </a:r>
+            <a:br>
+              <a:rPr lang="en-US" sz="2000" dirty="0">
+                <a:latin typeface="Times New Roman" panose="02020603050405020304" pitchFamily="18" charset="0"/>
+                <a:cs typeface="Times New Roman" panose="02020603050405020304" pitchFamily="18" charset="0"/>
+              </a:rPr>
+            </a:br>
+            <a:r>
+              <a:rPr lang="en-US" sz="2000" dirty="0">
+                <a:latin typeface="Times New Roman" panose="02020603050405020304" pitchFamily="18" charset="0"/>
+                <a:cs typeface="Times New Roman" panose="02020603050405020304" pitchFamily="18" charset="0"/>
+              </a:rPr>
+              <a:t>          </a:t>
+            </a:r>
+            <a:r>
+              <a:rPr lang="en-US" sz="1500" dirty="0">
+                <a:latin typeface="Times New Roman" panose="02020603050405020304" pitchFamily="18" charset="0"/>
+                <a:cs typeface="Times New Roman" panose="02020603050405020304" pitchFamily="18" charset="0"/>
+              </a:rPr>
+              <a:t>7</a:t>
+            </a:r>
+            <a:r>
+              <a:rPr lang="en-US" sz="2000" dirty="0">
+                <a:latin typeface="Times New Roman" panose="02020603050405020304" pitchFamily="18" charset="0"/>
+                <a:cs typeface="Times New Roman" panose="02020603050405020304" pitchFamily="18" charset="0"/>
+              </a:rPr>
+              <a:t>.</a:t>
+            </a:r>
+            <a:r>
+              <a:rPr lang="sq-AL" sz="1500" dirty="0">
+                <a:latin typeface="Times New Roman" panose="02020603050405020304" pitchFamily="18" charset="0"/>
+                <a:cs typeface="Times New Roman" panose="02020603050405020304" pitchFamily="18" charset="0"/>
+              </a:rPr>
+              <a:t>Rezultatet dhe përfundimet</a:t>
+            </a:r>
+            <a:br>
+              <a:rPr lang="en-US" sz="1500" dirty="0">
+                <a:latin typeface="Times New Roman" panose="02020603050405020304" pitchFamily="18" charset="0"/>
+                <a:cs typeface="Times New Roman" panose="02020603050405020304" pitchFamily="18" charset="0"/>
+              </a:rPr>
+            </a:br>
+            <a:r>
+              <a:rPr lang="en-US" sz="1500" dirty="0">
+                <a:latin typeface="Times New Roman" panose="02020603050405020304" pitchFamily="18" charset="0"/>
+                <a:cs typeface="Times New Roman" panose="02020603050405020304" pitchFamily="18" charset="0"/>
+              </a:rPr>
+              <a:t>             8. </a:t>
+            </a:r>
+            <a:r>
+              <a:rPr lang="en-US" sz="1500" dirty="0" err="1">
+                <a:latin typeface="Times New Roman" panose="02020603050405020304" pitchFamily="18" charset="0"/>
+                <a:cs typeface="Times New Roman" panose="02020603050405020304" pitchFamily="18" charset="0"/>
+              </a:rPr>
+              <a:t>Shtojcat</a:t>
+            </a:r>
+            <a:r>
+              <a:rPr lang="en-US" sz="1500" dirty="0">
+                <a:latin typeface="Times New Roman" panose="02020603050405020304" pitchFamily="18" charset="0"/>
+                <a:cs typeface="Times New Roman" panose="02020603050405020304" pitchFamily="18" charset="0"/>
+              </a:rPr>
+              <a:t> - </a:t>
+            </a:r>
+            <a:r>
+              <a:rPr lang="en-US" sz="1500" dirty="0" err="1">
+                <a:latin typeface="Times New Roman" panose="02020603050405020304" pitchFamily="18" charset="0"/>
+                <a:cs typeface="Times New Roman" panose="02020603050405020304" pitchFamily="18" charset="0"/>
+              </a:rPr>
+              <a:t>Hartat</a:t>
+            </a:r>
+            <a:r>
+              <a:rPr lang="en-US" sz="1500" dirty="0">
+                <a:latin typeface="Times New Roman" panose="02020603050405020304" pitchFamily="18" charset="0"/>
+                <a:cs typeface="Times New Roman" panose="02020603050405020304" pitchFamily="18" charset="0"/>
+              </a:rPr>
+              <a:t> </a:t>
+            </a:r>
+            <a:br>
+              <a:rPr lang="en-US" sz="1500" dirty="0">
+                <a:latin typeface="Times New Roman" panose="02020603050405020304" pitchFamily="18" charset="0"/>
+                <a:cs typeface="Times New Roman" panose="02020603050405020304" pitchFamily="18" charset="0"/>
+              </a:rPr>
+            </a:br>
+            <a:r>
+              <a:rPr lang="en-US" sz="1500" dirty="0">
+                <a:latin typeface="Times New Roman" panose="02020603050405020304" pitchFamily="18" charset="0"/>
+                <a:cs typeface="Times New Roman" panose="02020603050405020304" pitchFamily="18" charset="0"/>
+              </a:rPr>
+              <a:t>             9. </a:t>
+            </a:r>
+            <a:r>
+              <a:rPr lang="en-US" sz="1500" dirty="0" err="1">
+                <a:latin typeface="Times New Roman" panose="02020603050405020304" pitchFamily="18" charset="0"/>
+                <a:cs typeface="Times New Roman" panose="02020603050405020304" pitchFamily="18" charset="0"/>
+              </a:rPr>
+              <a:t>Literatura</a:t>
+            </a:r>
+            <a:br>
+              <a:rPr lang="en-US" sz="1500" dirty="0">
+                <a:latin typeface="Times New Roman" panose="02020603050405020304" pitchFamily="18" charset="0"/>
+                <a:cs typeface="Times New Roman" panose="02020603050405020304" pitchFamily="18" charset="0"/>
+              </a:rPr>
+            </a:br>
+            <a:r>
+              <a:rPr lang="en-US" sz="1500" dirty="0">
+                <a:latin typeface="Times New Roman" panose="02020603050405020304" pitchFamily="18" charset="0"/>
+                <a:cs typeface="Times New Roman" panose="02020603050405020304" pitchFamily="18" charset="0"/>
+              </a:rPr>
+              <a:t>	</a:t>
+            </a:r>
+            <a:endParaRPr lang="en-US" dirty="0"/>
+          </a:p>
+        </p:txBody>
+      </p:sp>
+    </p:spTree>
+    <p:extLst>
+      <p:ext uri="{BB962C8B-B14F-4D97-AF65-F5344CB8AC3E}">
+        <p14:creationId xmlns:p14="http://schemas.microsoft.com/office/powerpoint/2010/main" val="710877147"/>
+      </p:ext>
+    </p:extLst>
+  </p:cSld>
+  <p:clrMapOvr>
+    <a:masterClrMapping/>
+  </p:clrMapOvr>
+</p:sld>
+</file>
+
+<file path=ppt/slides/slide4.xml><?xml version="1.0" encoding="utf-8"?>
+<p:sld xmlns:a="http://schemas.openxmlformats.org/drawingml/2006/main" xmlns:r="http://schemas.openxmlformats.org/officeDocument/2006/relationships" xmlns:p="http://schemas.openxmlformats.org/presentationml/2006/main">
+  <p:cSld>
+    <p:spTree>
+      <p:nvGrpSpPr>
+        <p:cNvPr id="1" name=""/>
+        <p:cNvGrpSpPr/>
+        <p:nvPr/>
+      </p:nvGrpSpPr>
+      <p:grpSpPr>
+        <a:xfrm>
+          <a:off x="0" y="0"/>
+          <a:ext cx="0" cy="0"/>
+          <a:chOff x="0" y="0"/>
+          <a:chExt cx="0" cy="0"/>
+        </a:xfrm>
+      </p:grpSpPr>
+      <p:sp>
+        <p:nvSpPr>
+          <p:cNvPr id="2" name="Title 1">
+            <a:extLst>
+              <a:ext uri="{FF2B5EF4-FFF2-40B4-BE49-F238E27FC236}">
+                <a16:creationId xmlns:a16="http://schemas.microsoft.com/office/drawing/2014/main" id="{8017D315-D284-43E5-8F20-D0F96629CF47}"/>
+              </a:ext>
+            </a:extLst>
+          </p:cNvPr>
+          <p:cNvSpPr>
+            <a:spLocks noGrp="1"/>
+          </p:cNvSpPr>
+          <p:nvPr>
+            <p:ph type="title"/>
+          </p:nvPr>
+        </p:nvSpPr>
+        <p:spPr>
+          <a:xfrm>
+            <a:off x="3899162" y="271777"/>
+            <a:ext cx="4393676" cy="568129"/>
+          </a:xfrm>
+        </p:spPr>
+        <p:txBody>
+          <a:bodyPr>
+            <a:noAutofit/>
+          </a:bodyPr>
+          <a:lstStyle/>
+          <a:p>
+            <a:pPr algn="ctr"/>
+            <a:r>
+              <a:rPr lang="sq-AL" sz="2500" b="1" u="sng" dirty="0">
+                <a:latin typeface="Times New Roman" panose="02020603050405020304" pitchFamily="18" charset="0"/>
+                <a:cs typeface="Times New Roman" panose="02020603050405020304" pitchFamily="18" charset="0"/>
+              </a:rPr>
+              <a:t>Përmbajtja</a:t>
+            </a:r>
+            <a:r>
+              <a:rPr lang="en-US" sz="2500" b="1" u="sng" dirty="0">
+                <a:latin typeface="Times New Roman" panose="02020603050405020304" pitchFamily="18" charset="0"/>
+                <a:cs typeface="Times New Roman" panose="02020603050405020304" pitchFamily="18" charset="0"/>
+              </a:rPr>
+              <a:t>:</a:t>
+            </a:r>
+            <a:endParaRPr lang="en-US" sz="2500" b="1" u="sng" dirty="0"/>
+          </a:p>
+        </p:txBody>
+      </p:sp>
+      <p:pic>
+        <p:nvPicPr>
+          <p:cNvPr id="12" name="Picture 11">
+            <a:extLst>
+              <a:ext uri="{FF2B5EF4-FFF2-40B4-BE49-F238E27FC236}">
+                <a16:creationId xmlns:a16="http://schemas.microsoft.com/office/drawing/2014/main" id="{EB987507-9C5E-4ADB-B32F-EB12EA54B135}"/>
+              </a:ext>
+            </a:extLst>
+          </p:cNvPr>
+          <p:cNvPicPr>
+            <a:picLocks noChangeAspect="1"/>
+          </p:cNvPicPr>
+          <p:nvPr/>
+        </p:nvPicPr>
+        <p:blipFill>
+          <a:blip r:embed="rId2"/>
+          <a:stretch>
+            <a:fillRect/>
+          </a:stretch>
+        </p:blipFill>
+        <p:spPr>
+          <a:xfrm>
+            <a:off x="1223857" y="839906"/>
+            <a:ext cx="9744286" cy="5952106"/>
+          </a:xfrm>
+          <a:prstGeom prst="rect">
+            <a:avLst/>
+          </a:prstGeom>
+        </p:spPr>
+      </p:pic>
+    </p:spTree>
+    <p:extLst>
+      <p:ext uri="{BB962C8B-B14F-4D97-AF65-F5344CB8AC3E}">
+        <p14:creationId xmlns:p14="http://schemas.microsoft.com/office/powerpoint/2010/main" val="59812200"/>
+      </p:ext>
+    </p:extLst>
+  </p:cSld>
+  <p:clrMapOvr>
+    <a:masterClrMapping/>
+  </p:clrMapOvr>
+</p:sld>
+</file>
+
+<file path=ppt/slides/slide5.xml><?xml version="1.0" encoding="utf-8"?>
+<p:sld xmlns:a="http://schemas.openxmlformats.org/drawingml/2006/main" xmlns:r="http://schemas.openxmlformats.org/officeDocument/2006/relationships" xmlns:p="http://schemas.openxmlformats.org/presentationml/2006/main">
+  <p:cSld>
+    <p:spTree>
+      <p:nvGrpSpPr>
+        <p:cNvPr id="1" name=""/>
+        <p:cNvGrpSpPr/>
+        <p:nvPr/>
+      </p:nvGrpSpPr>
+      <p:grpSpPr>
+        <a:xfrm>
+          <a:off x="0" y="0"/>
+          <a:ext cx="0" cy="0"/>
+          <a:chOff x="0" y="0"/>
+          <a:chExt cx="0" cy="0"/>
+        </a:xfrm>
+      </p:grpSpPr>
+      <p:sp>
+        <p:nvSpPr>
+          <p:cNvPr id="2" name="Title 1">
+            <a:extLst>
+              <a:ext uri="{FF2B5EF4-FFF2-40B4-BE49-F238E27FC236}">
                 <a16:creationId xmlns:a16="http://schemas.microsoft.com/office/drawing/2014/main" id="{4D3BB08C-54B8-491D-8024-E494A0AA3D9A}"/>
               </a:ext>
             </a:extLst>
@@ -7889,7 +8513,7 @@
 </p:sld>
 </file>
 
-<file path=ppt/slides/slide4.xml><?xml version="1.0" encoding="utf-8"?>
+<file path=ppt/slides/slide6.xml><?xml version="1.0" encoding="utf-8"?>
 <p:sld xmlns:a="http://schemas.openxmlformats.org/drawingml/2006/main" xmlns:r="http://schemas.openxmlformats.org/officeDocument/2006/relationships" xmlns:p="http://schemas.openxmlformats.org/presentationml/2006/main">
   <p:cSld>
     <p:spTree>
@@ -8010,10 +8634,22 @@
   <p:clrMapOvr>
     <a:masterClrMapping/>
   </p:clrMapOvr>
+  <mc:AlternateContent xmlns:mc="http://schemas.openxmlformats.org/markup-compatibility/2006" xmlns:p159="http://schemas.microsoft.com/office/powerpoint/2015/09/main">
+    <mc:Choice Requires="p159">
+      <p:transition xmlns:p14="http://schemas.microsoft.com/office/powerpoint/2010/main" spd="slow" p14:dur="2000">
+        <p159:morph option="byObject"/>
+      </p:transition>
+    </mc:Choice>
+    <mc:Fallback xmlns="">
+      <p:transition spd="slow">
+        <p:fade/>
+      </p:transition>
+    </mc:Fallback>
+  </mc:AlternateContent>
 </p:sld>
 </file>
 
-<file path=ppt/slides/slide5.xml><?xml version="1.0" encoding="utf-8"?>
+<file path=ppt/slides/slide7.xml><?xml version="1.0" encoding="utf-8"?>
 <p:sld xmlns:a="http://schemas.openxmlformats.org/drawingml/2006/main" xmlns:r="http://schemas.openxmlformats.org/officeDocument/2006/relationships" xmlns:p="http://schemas.openxmlformats.org/presentationml/2006/main">
   <p:cSld>
     <p:spTree>
@@ -8082,7 +8718,7 @@
 </p:sld>
 </file>
 
-<file path=ppt/slides/slide6.xml><?xml version="1.0" encoding="utf-8"?>
+<file path=ppt/slides/slide8.xml><?xml version="1.0" encoding="utf-8"?>
 <p:sld xmlns:a="http://schemas.openxmlformats.org/drawingml/2006/main" xmlns:r="http://schemas.openxmlformats.org/officeDocument/2006/relationships" xmlns:p="http://schemas.openxmlformats.org/presentationml/2006/main">
   <p:cSld>
     <p:spTree>
@@ -8365,6 +9001,201 @@
     <p:extLst>
       <p:ext uri="{BB962C8B-B14F-4D97-AF65-F5344CB8AC3E}">
         <p14:creationId xmlns:p14="http://schemas.microsoft.com/office/powerpoint/2010/main" val="156620868"/>
+      </p:ext>
+    </p:extLst>
+  </p:cSld>
+  <p:clrMapOvr>
+    <a:masterClrMapping/>
+  </p:clrMapOvr>
+</p:sld>
+</file>
+
+<file path=ppt/slides/slide9.xml><?xml version="1.0" encoding="utf-8"?>
+<p:sld xmlns:a="http://schemas.openxmlformats.org/drawingml/2006/main" xmlns:r="http://schemas.openxmlformats.org/officeDocument/2006/relationships" xmlns:p="http://schemas.openxmlformats.org/presentationml/2006/main">
+  <p:cSld>
+    <p:spTree>
+      <p:nvGrpSpPr>
+        <p:cNvPr id="1" name=""/>
+        <p:cNvGrpSpPr/>
+        <p:nvPr/>
+      </p:nvGrpSpPr>
+      <p:grpSpPr>
+        <a:xfrm>
+          <a:off x="0" y="0"/>
+          <a:ext cx="0" cy="0"/>
+          <a:chOff x="0" y="0"/>
+          <a:chExt cx="0" cy="0"/>
+        </a:xfrm>
+      </p:grpSpPr>
+      <p:pic>
+        <p:nvPicPr>
+          <p:cNvPr id="5" name="Picture 4">
+            <a:extLst>
+              <a:ext uri="{FF2B5EF4-FFF2-40B4-BE49-F238E27FC236}">
+                <a16:creationId xmlns:a16="http://schemas.microsoft.com/office/drawing/2014/main" id="{CC120C14-2D0D-4010-B392-5C95B5F76639}"/>
+              </a:ext>
+            </a:extLst>
+          </p:cNvPr>
+          <p:cNvPicPr>
+            <a:picLocks noChangeAspect="1"/>
+          </p:cNvPicPr>
+          <p:nvPr/>
+        </p:nvPicPr>
+        <p:blipFill rotWithShape="1">
+          <a:blip r:embed="rId2">
+            <a:extLst>
+              <a:ext uri="{28A0092B-C50C-407E-A947-70E740481C1C}">
+                <a14:useLocalDpi xmlns:a14="http://schemas.microsoft.com/office/drawing/2010/main" val="0"/>
+              </a:ext>
+            </a:extLst>
+          </a:blip>
+          <a:srcRect t="12500" b="12500"/>
+          <a:stretch/>
+        </p:blipFill>
+        <p:spPr>
+          <a:xfrm>
+            <a:off x="0" y="0"/>
+            <a:ext cx="12192000" cy="6858000"/>
+          </a:xfrm>
+          <a:prstGeom prst="rect">
+            <a:avLst/>
+          </a:prstGeom>
+        </p:spPr>
+      </p:pic>
+      <p:sp>
+        <p:nvSpPr>
+          <p:cNvPr id="6" name="Rectangle 5">
+            <a:extLst>
+              <a:ext uri="{FF2B5EF4-FFF2-40B4-BE49-F238E27FC236}">
+                <a16:creationId xmlns:a16="http://schemas.microsoft.com/office/drawing/2014/main" id="{D1980F2D-C61E-4568-8850-46666ABE0080}"/>
+              </a:ext>
+            </a:extLst>
+          </p:cNvPr>
+          <p:cNvSpPr/>
+          <p:nvPr/>
+        </p:nvSpPr>
+        <p:spPr>
+          <a:xfrm>
+            <a:off x="0" y="0"/>
+            <a:ext cx="12192000" cy="6858000"/>
+          </a:xfrm>
+          <a:prstGeom prst="rect">
+            <a:avLst/>
+          </a:prstGeom>
+          <a:solidFill>
+            <a:schemeClr val="bg1"/>
+          </a:solidFill>
+          <a:ln>
+            <a:noFill/>
+          </a:ln>
+        </p:spPr>
+        <p:style>
+          <a:lnRef idx="2">
+            <a:schemeClr val="accent1">
+              <a:shade val="50000"/>
+            </a:schemeClr>
+          </a:lnRef>
+          <a:fillRef idx="1">
+            <a:schemeClr val="accent1"/>
+          </a:fillRef>
+          <a:effectRef idx="0">
+            <a:schemeClr val="accent1"/>
+          </a:effectRef>
+          <a:fontRef idx="minor">
+            <a:schemeClr val="lt1"/>
+          </a:fontRef>
+        </p:style>
+        <p:txBody>
+          <a:bodyPr rtlCol="0" anchor="ctr"/>
+          <a:lstStyle/>
+          <a:p>
+            <a:pPr algn="ctr"/>
+            <a:endParaRPr lang="en-US"/>
+          </a:p>
+        </p:txBody>
+      </p:sp>
+      <p:sp>
+        <p:nvSpPr>
+          <p:cNvPr id="7" name="TextBox 6">
+            <a:extLst>
+              <a:ext uri="{FF2B5EF4-FFF2-40B4-BE49-F238E27FC236}">
+                <a16:creationId xmlns:a16="http://schemas.microsoft.com/office/drawing/2014/main" id="{E4BA0B3E-1EFE-4709-AB0F-CDDDC06E1277}"/>
+              </a:ext>
+            </a:extLst>
+          </p:cNvPr>
+          <p:cNvSpPr txBox="1"/>
+          <p:nvPr/>
+        </p:nvSpPr>
+        <p:spPr>
+          <a:xfrm>
+            <a:off x="821703" y="2274838"/>
+            <a:ext cx="10548594" cy="2308324"/>
+          </a:xfrm>
+          <a:prstGeom prst="rect">
+            <a:avLst/>
+          </a:prstGeom>
+          <a:noFill/>
+        </p:spPr>
+        <p:txBody>
+          <a:bodyPr wrap="square" rtlCol="0">
+            <a:spAutoFit/>
+          </a:bodyPr>
+          <a:lstStyle/>
+          <a:p>
+            <a:pPr lvl="1" algn="ctr"/>
+            <a:r>
+              <a:rPr lang="en-US" sz="7200" spc="600" dirty="0">
+                <a:latin typeface="Call Of Ops Duty" panose="02000500000000000000" pitchFamily="2" charset="0"/>
+                <a:cs typeface="Times New Roman" panose="02020603050405020304" pitchFamily="18" charset="0"/>
+              </a:rPr>
+              <a:t> </a:t>
+            </a:r>
+            <a:r>
+              <a:rPr lang="en-US" sz="7200" b="1" spc="600" dirty="0">
+                <a:latin typeface="Call Of Ops Duty" panose="02000500000000000000" pitchFamily="2" charset="0"/>
+                <a:cs typeface="Times New Roman" panose="02020603050405020304" pitchFamily="18" charset="0"/>
+              </a:rPr>
+              <a:t>JU FALEMINDERIT </a:t>
+            </a:r>
+            <a:r>
+              <a:rPr lang="en-US" sz="7200" b="1" spc="600" dirty="0" err="1">
+                <a:latin typeface="Call Of Ops Duty" panose="02000500000000000000" pitchFamily="2" charset="0"/>
+                <a:cs typeface="Times New Roman" panose="02020603050405020304" pitchFamily="18" charset="0"/>
+              </a:rPr>
+              <a:t>PeR</a:t>
+            </a:r>
+            <a:r>
+              <a:rPr lang="en-US" sz="7200" b="1" spc="600" dirty="0">
+                <a:latin typeface="Call Of Ops Duty" panose="02000500000000000000" pitchFamily="2" charset="0"/>
+                <a:cs typeface="Times New Roman" panose="02020603050405020304" pitchFamily="18" charset="0"/>
+              </a:rPr>
+              <a:t> </a:t>
+            </a:r>
+            <a:r>
+              <a:rPr lang="en-US" sz="7200" b="1" spc="600" dirty="0" err="1">
+                <a:latin typeface="Call Of Ops Duty" panose="02000500000000000000" pitchFamily="2" charset="0"/>
+                <a:cs typeface="Times New Roman" panose="02020603050405020304" pitchFamily="18" charset="0"/>
+              </a:rPr>
+              <a:t>VeMENDJEN</a:t>
+            </a:r>
+            <a:r>
+              <a:rPr lang="en-US" sz="7200" b="1" spc="600" dirty="0">
+                <a:latin typeface="Call Of Ops Duty" panose="02000500000000000000" pitchFamily="2" charset="0"/>
+                <a:cs typeface="Times New Roman" panose="02020603050405020304" pitchFamily="18" charset="0"/>
+              </a:rPr>
+              <a:t> TUAJ.</a:t>
+            </a:r>
+            <a:endParaRPr lang="en-US" sz="9600" b="1" spc="600" dirty="0">
+              <a:latin typeface="Call Of Ops Duty" panose="02000500000000000000" pitchFamily="2" charset="0"/>
+              <a:cs typeface="Times New Roman" panose="02020603050405020304" pitchFamily="18" charset="0"/>
+            </a:endParaRPr>
+          </a:p>
+        </p:txBody>
+      </p:sp>
+    </p:spTree>
+    <p:extLst>
+      <p:ext uri="{BB962C8B-B14F-4D97-AF65-F5344CB8AC3E}">
+        <p14:creationId xmlns:p14="http://schemas.microsoft.com/office/powerpoint/2010/main" val="723881032"/>
       </p:ext>
     </p:extLst>
   </p:cSld>

</xml_diff>